<commit_message>
Fig. 1 pptx 원본 갱신
Co-Authored-By: Claude Opus 5.5 <noreply@anthropic.com>
</commit_message>
<xml_diff>
--- a/figures/ppt/fig1_framework.pptx
+++ b/figures/ppt/fig1_framework.pptx
@@ -4043,7 +4043,7 @@
                 </a:solidFill>
                 <a:latin typeface="Times New Roman"/>
               </a:rPr>
-              <a:t>  by adversarial RL on the SMDP</a:t>
+              <a:t>  by adversarial RL with legality masking</a:t>
             </a:r>
           </a:p>
         </p:txBody>
@@ -9350,7 +9350,25 @@
                 </a:solidFill>
                 <a:latin typeface="Times New Roman"/>
               </a:rPr>
-              <a:t>one gear decision = option, gear held for </a:t>
+              <a:t>unroll over </a:t>
+            </a:r>
+            <a:r>
+              <a:rPr sz="630" b="0" i="1">
+                <a:solidFill>
+                  <a:srgbClr val="A65E1A"/>
+                </a:solidFill>
+                <a:latin typeface="Times New Roman"/>
+              </a:rPr>
+              <a:t>n</a:t>
+            </a:r>
+            <a:r>
+              <a:rPr sz="630" b="0" i="0">
+                <a:solidFill>
+                  <a:srgbClr val="A65E1A"/>
+                </a:solidFill>
+                <a:latin typeface="Times New Roman"/>
+              </a:rPr>
+              <a:t> ≥ </a:t>
             </a:r>
             <a:r>
               <a:rPr sz="630" b="0" i="1">
@@ -9377,14 +9395,14 @@
                 </a:solidFill>
                 <a:latin typeface="Times New Roman"/>
               </a:rPr>
-              <a:t> steps</a:t>
+              <a:t> steps, legal gear chosen at every step</a:t>
             </a:r>
           </a:p>
         </p:txBody>
       </p:sp>
       <p:sp>
         <p:nvSpPr>
-          <p:cNvPr id="155" name="option_step_0"/>
+          <p:cNvPr id="155" name="unroll_step_0"/>
           <p:cNvSpPr/>
           <p:nvPr/>
         </p:nvSpPr>
@@ -9399,7 +9417,7 @@
             </a:avLst>
           </a:prstGeom>
           <a:solidFill>
-            <a:srgbClr val="FBEFE3"/>
+            <a:srgbClr val="FFFFFF"/>
           </a:solidFill>
           <a:ln w="8890">
             <a:solidFill>
@@ -9440,14 +9458,23 @@
                 </a:solidFill>
                 <a:latin typeface="Times New Roman"/>
               </a:rPr>
-              <a:t>ĝ</a:t>
+              <a:t>g</a:t>
+            </a:r>
+            <a:r>
+              <a:rPr sz="640" b="0" i="1" baseline="-25000">
+                <a:solidFill>
+                  <a:srgbClr val="000000"/>
+                </a:solidFill>
+                <a:latin typeface="Times New Roman"/>
+              </a:rPr>
+              <a:t>c</a:t>
             </a:r>
           </a:p>
         </p:txBody>
       </p:sp>
       <p:sp>
         <p:nvSpPr>
-          <p:cNvPr id="156" name="option_step_1"/>
+          <p:cNvPr id="156" name="unroll_step_1"/>
           <p:cNvSpPr/>
           <p:nvPr/>
         </p:nvSpPr>
@@ -9503,14 +9530,23 @@
                 </a:solidFill>
                 <a:latin typeface="Times New Roman"/>
               </a:rPr>
-              <a:t>ĝ</a:t>
+              <a:t>g</a:t>
+            </a:r>
+            <a:r>
+              <a:rPr sz="640" b="0" i="0">
+                <a:solidFill>
+                  <a:srgbClr val="000000"/>
+                </a:solidFill>
+                <a:latin typeface="Times New Roman"/>
+              </a:rPr>
+              <a:t>*</a:t>
             </a:r>
           </a:p>
         </p:txBody>
       </p:sp>
       <p:sp>
         <p:nvSpPr>
-          <p:cNvPr id="157" name="option_step_2"/>
+          <p:cNvPr id="157" name="unroll_step_2"/>
           <p:cNvSpPr/>
           <p:nvPr/>
         </p:nvSpPr>
@@ -9566,14 +9602,23 @@
                 </a:solidFill>
                 <a:latin typeface="Times New Roman"/>
               </a:rPr>
-              <a:t>ĝ</a:t>
+              <a:t>g</a:t>
+            </a:r>
+            <a:r>
+              <a:rPr sz="640" b="0" i="0">
+                <a:solidFill>
+                  <a:srgbClr val="000000"/>
+                </a:solidFill>
+                <a:latin typeface="Times New Roman"/>
+              </a:rPr>
+              <a:t>*</a:t>
             </a:r>
           </a:p>
         </p:txBody>
       </p:sp>
       <p:sp>
         <p:nvSpPr>
-          <p:cNvPr id="158" name="option_step_3"/>
+          <p:cNvPr id="158" name="unroll_step_3"/>
           <p:cNvSpPr/>
           <p:nvPr/>
         </p:nvSpPr>
@@ -9629,14 +9674,23 @@
                 </a:solidFill>
                 <a:latin typeface="Times New Roman"/>
               </a:rPr>
-              <a:t>ĝ</a:t>
+              <a:t>g</a:t>
+            </a:r>
+            <a:r>
+              <a:rPr sz="640" b="0" i="0">
+                <a:solidFill>
+                  <a:srgbClr val="000000"/>
+                </a:solidFill>
+                <a:latin typeface="Times New Roman"/>
+              </a:rPr>
+              <a:t>*</a:t>
             </a:r>
           </a:p>
         </p:txBody>
       </p:sp>
       <p:sp>
         <p:nvSpPr>
-          <p:cNvPr id="159" name="option_step_4"/>
+          <p:cNvPr id="159" name="unroll_step_4"/>
           <p:cNvSpPr/>
           <p:nvPr/>
         </p:nvSpPr>
@@ -9692,14 +9746,23 @@
                 </a:solidFill>
                 <a:latin typeface="Times New Roman"/>
               </a:rPr>
-              <a:t>ĝ</a:t>
+              <a:t>g</a:t>
+            </a:r>
+            <a:r>
+              <a:rPr sz="640" b="0" i="0">
+                <a:solidFill>
+                  <a:srgbClr val="000000"/>
+                </a:solidFill>
+                <a:latin typeface="Times New Roman"/>
+              </a:rPr>
+              <a:t>*</a:t>
             </a:r>
           </a:p>
         </p:txBody>
       </p:sp>
       <p:sp>
         <p:nvSpPr>
-          <p:cNvPr id="160" name="option_step_5"/>
+          <p:cNvPr id="160" name="unroll_step_5"/>
           <p:cNvSpPr/>
           <p:nvPr/>
         </p:nvSpPr>
@@ -9749,13 +9812,13 @@
               </a:lnSpc>
             </a:pPr>
             <a:r>
-              <a:rPr sz="640" b="0" i="1">
+              <a:rPr sz="640" b="0" i="0">
                 <a:solidFill>
                   <a:srgbClr val="000000"/>
                 </a:solidFill>
                 <a:latin typeface="Times New Roman"/>
               </a:rPr>
-              <a:t>ĝ</a:t>
+              <a:t>…</a:t>
             </a:r>
           </a:p>
         </p:txBody>

</xml_diff>

<commit_message>
Safety Critics: fold 변수를 g_j 에서 y_j 로 (gear 기호와 구분), 식 앞에서 y 를 critic 회귀 target 으로 정의, y_j 의미 추가, joint action 표현 정리. Fig. 1 fold 식도 y_j 로
Co-Authored-By: Claude Opus 5.5 <noreply@anthropic.com>
</commit_message>
<xml_diff>
--- a/figures/ppt/fig1_framework.pptx
+++ b/figures/ppt/fig1_framework.pptx
@@ -10368,7 +10368,7 @@
                 </a:solidFill>
                 <a:latin typeface="Times New Roman"/>
               </a:rPr>
-              <a:t>g</a:t>
+              <a:t>y</a:t>
             </a:r>
             <a:r>
               <a:rPr sz="630" b="0" i="1" baseline="-25000">
@@ -10503,7 +10503,7 @@
                 </a:solidFill>
                 <a:latin typeface="Times New Roman"/>
               </a:rPr>
-              <a:t>g</a:t>
+              <a:t>y</a:t>
             </a:r>
             <a:r>
               <a:rPr sz="630" b="0" i="1" baseline="-25000">
@@ -10548,7 +10548,7 @@
                 </a:solidFill>
                 <a:latin typeface="Times New Roman"/>
               </a:rPr>
-              <a:t>g</a:t>
+              <a:t>y</a:t>
             </a:r>
             <a:r>
               <a:rPr sz="630" b="0" i="1" baseline="-25000">

</xml_diff>